<commit_message>
fix(entrega3): corregir orden XML del fondo que corrompia la pptx en PowerPoint
El gradiente del fondo se insertaba despues del <a:effectLst> que python-pptx
deja en el bgPr, violando el orden del esquema OOXML. LibreOffice lo toleraba
pero PowerPoint marcaba el archivo como corrupto. Ahora el relleno va antes.
</commit_message>
<xml_diff>
--- a/CampusLink_Presentacion_E3.pptx
+++ b/CampusLink_Presentacion_E3.pptx
@@ -5278,7 +5278,6 @@
   <p:cSld>
     <p:bg>
       <p:bgPr>
-        <a:effectLst/>
         <a:gradFill rotWithShape="1">
           <a:gsLst>
             <a:gs pos="0">
@@ -5290,6 +5289,7 @@
           </a:gsLst>
           <a:lin ang="3600000" scaled="1"/>
         </a:gradFill>
+        <a:effectLst/>
       </p:bgPr>
     </p:bg>
     <p:spTree>
@@ -10691,7 +10691,6 @@
   <p:cSld>
     <p:bg>
       <p:bgPr>
-        <a:effectLst/>
         <a:gradFill rotWithShape="1">
           <a:gsLst>
             <a:gs pos="0">
@@ -10703,6 +10702,7 @@
           </a:gsLst>
           <a:lin ang="3300000" scaled="1"/>
         </a:gradFill>
+        <a:effectLst/>
       </p:bgPr>
     </p:bg>
     <p:spTree>
@@ -17294,7 +17294,6 @@
   <p:cSld>
     <p:bg>
       <p:bgPr>
-        <a:effectLst/>
         <a:gradFill rotWithShape="1">
           <a:gsLst>
             <a:gs pos="0">
@@ -17306,6 +17305,7 @@
           </a:gsLst>
           <a:lin ang="3300000" scaled="1"/>
         </a:gradFill>
+        <a:effectLst/>
       </p:bgPr>
     </p:bg>
     <p:spTree>
@@ -19956,7 +19956,6 @@
   <p:cSld>
     <p:bg>
       <p:bgPr>
-        <a:effectLst/>
         <a:gradFill rotWithShape="1">
           <a:gsLst>
             <a:gs pos="0">
@@ -19968,6 +19967,7 @@
           </a:gsLst>
           <a:lin ang="3600000" scaled="1"/>
         </a:gradFill>
+        <a:effectLst/>
       </p:bgPr>
     </p:bg>
     <p:spTree>
@@ -20996,7 +20996,6 @@
   <p:cSld>
     <p:bg>
       <p:bgPr>
-        <a:effectLst/>
         <a:gradFill rotWithShape="1">
           <a:gsLst>
             <a:gs pos="0">
@@ -21008,6 +21007,7 @@
           </a:gsLst>
           <a:lin ang="3300000" scaled="1"/>
         </a:gradFill>
+        <a:effectLst/>
       </p:bgPr>
     </p:bg>
     <p:spTree>
@@ -24590,7 +24590,6 @@
   <p:cSld>
     <p:bg>
       <p:bgPr>
-        <a:effectLst/>
         <a:gradFill rotWithShape="1">
           <a:gsLst>
             <a:gs pos="0">
@@ -24602,6 +24601,7 @@
           </a:gsLst>
           <a:lin ang="3300000" scaled="1"/>
         </a:gradFill>
+        <a:effectLst/>
       </p:bgPr>
     </p:bg>
     <p:spTree>

</xml_diff>